<commit_message>
Add career and honors timeline to profile slide
</commit_message>
<xml_diff>
--- a/outputs/ability-demo-v5.pptx
+++ b/outputs/ability-demo-v5.pptx
@@ -2,18 +2,18 @@
 <file path=ppt/presentation.xml><?xml version="1.0" encoding="utf-8"?>
 <p:presentation xmlns:p="http://schemas.openxmlformats.org/presentationml/2006/main">
   <p:sldMasterIdLst>
-    <p:sldMasterId xmlns:r="http://schemas.openxmlformats.org/officeDocument/2006/relationships" id="2147483648" r:id="R5318b15770bd4cd2"/>
+    <p:sldMasterId xmlns:r="http://schemas.openxmlformats.org/officeDocument/2006/relationships" id="2147483648" r:id="R912b874d2e67483f"/>
   </p:sldMasterIdLst>
   <p:notesMasterIdLst>
-    <p:notesMasterId xmlns:r="http://schemas.openxmlformats.org/officeDocument/2006/relationships" r:id="R867025f59653436a"/>
+    <p:notesMasterId xmlns:r="http://schemas.openxmlformats.org/officeDocument/2006/relationships" r:id="R05726b2250a845cb"/>
   </p:notesMasterIdLst>
   <p:sldIdLst>
-    <p:sldId xmlns:r="http://schemas.openxmlformats.org/officeDocument/2006/relationships" id="256" r:id="R2adcae2d92ed49cc"/>
-    <p:sldId xmlns:r="http://schemas.openxmlformats.org/officeDocument/2006/relationships" id="257" r:id="Red03f8f58751442b"/>
-    <p:sldId xmlns:r="http://schemas.openxmlformats.org/officeDocument/2006/relationships" id="258" r:id="R1feb1cad7380408d"/>
-    <p:sldId xmlns:r="http://schemas.openxmlformats.org/officeDocument/2006/relationships" id="259" r:id="R2ca899eee2a3428a"/>
-    <p:sldId xmlns:r="http://schemas.openxmlformats.org/officeDocument/2006/relationships" id="260" r:id="Re4a110da200d4fb3"/>
-    <p:sldId xmlns:r="http://schemas.openxmlformats.org/officeDocument/2006/relationships" id="261" r:id="R001f278a823e4295"/>
+    <p:sldId xmlns:r="http://schemas.openxmlformats.org/officeDocument/2006/relationships" id="256" r:id="R0db13da6b8494067"/>
+    <p:sldId xmlns:r="http://schemas.openxmlformats.org/officeDocument/2006/relationships" id="257" r:id="Rc0089013b30c45ff"/>
+    <p:sldId xmlns:r="http://schemas.openxmlformats.org/officeDocument/2006/relationships" id="258" r:id="Rf7cff6414d5c47cb"/>
+    <p:sldId xmlns:r="http://schemas.openxmlformats.org/officeDocument/2006/relationships" id="259" r:id="Rfee9c4db10b049b1"/>
+    <p:sldId xmlns:r="http://schemas.openxmlformats.org/officeDocument/2006/relationships" id="260" r:id="Re7c962c260044e18"/>
+    <p:sldId xmlns:r="http://schemas.openxmlformats.org/officeDocument/2006/relationships" id="261" r:id="Re639a0a2488e4693"/>
   </p:sldIdLst>
   <p:sldSz cx="12192000" cy="6858000"/>
   <p:notesSz cx="6858000" cy="9144000"/>
@@ -925,7 +925,7 @@
   </p:cSld>
   <p:clrMap bg1="lt1" tx1="dk1" bg2="lt2" tx2="dk2" accent1="accent1" accent2="accent2" accent3="accent3" accent4="accent4" accent5="accent5" accent6="accent6" hlink="hlink" folHlink="folHlink"/>
   <p:sldLayoutIdLst>
-    <p:sldLayoutId xmlns:r="http://schemas.openxmlformats.org/officeDocument/2006/relationships" id="2147483649" r:id="Re763ec16b50f4502"/>
+    <p:sldLayoutId xmlns:r="http://schemas.openxmlformats.org/officeDocument/2006/relationships" id="2147483649" r:id="R1de4d8fbee5e4d72"/>
   </p:sldLayoutIdLst>
   <p:txStyles>
     <p:titleStyle>
@@ -1473,7 +1473,7 @@
           <p:nvPr/>
         </p:nvPicPr>
         <p:blipFill>
-          <a:blip xmlns:r="http://schemas.openxmlformats.org/officeDocument/2006/relationships" xmlns:a="http://schemas.openxmlformats.org/drawingml/2006/main" r:embed="Rbb67dd353bb74898"/>
+          <a:blip xmlns:r="http://schemas.openxmlformats.org/officeDocument/2006/relationships" xmlns:a="http://schemas.openxmlformats.org/drawingml/2006/main" r:embed="R615118be5fe14f8a"/>
           <a:srcRect xmlns:a="http://schemas.openxmlformats.org/drawingml/2006/main" l="0" t="0" r="0" b="0"/>
           <a:stretch xmlns:a="http://schemas.openxmlformats.org/drawingml/2006/main">
             <a:fillRect l="0" t="0" r="0" b="0"/>
@@ -1492,7 +1492,7 @@
     </p:spTree>
     <p:extLst>
       <p:ext uri="{BB962C8B-B14F-4D97-AF65-F5344CB8AC3E}">
-        <p14:creationId xmlns:p14="http://schemas.microsoft.com/office/powerpoint/2010/main" val="8109105"/>
+        <p14:creationId xmlns:p14="http://schemas.microsoft.com/office/powerpoint/2010/main" val="170170889"/>
       </p:ext>
     </p:extLst>
   </p:cSld>
@@ -1520,7 +1520,7 @@
           <p:nvPr/>
         </p:nvPicPr>
         <p:blipFill>
-          <a:blip xmlns:r="http://schemas.openxmlformats.org/officeDocument/2006/relationships" xmlns:a="http://schemas.openxmlformats.org/drawingml/2006/main" r:embed="R34d24537e8c14b51"/>
+          <a:blip xmlns:r="http://schemas.openxmlformats.org/officeDocument/2006/relationships" xmlns:a="http://schemas.openxmlformats.org/drawingml/2006/main" r:embed="R03312485a2824ece"/>
           <a:srcRect xmlns:a="http://schemas.openxmlformats.org/drawingml/2006/main" l="0" t="0" r="0" b="0"/>
           <a:stretch xmlns:a="http://schemas.openxmlformats.org/drawingml/2006/main">
             <a:fillRect l="0" t="0" r="0" b="0"/>
@@ -1539,7 +1539,7 @@
     </p:spTree>
     <p:extLst>
       <p:ext uri="{BB962C8B-B14F-4D97-AF65-F5344CB8AC3E}">
-        <p14:creationId xmlns:p14="http://schemas.microsoft.com/office/powerpoint/2010/main" val="624616484"/>
+        <p14:creationId xmlns:p14="http://schemas.microsoft.com/office/powerpoint/2010/main" val="1353455036"/>
       </p:ext>
     </p:extLst>
   </p:cSld>
@@ -1567,7 +1567,7 @@
           <p:nvPr/>
         </p:nvPicPr>
         <p:blipFill>
-          <a:blip xmlns:r="http://schemas.openxmlformats.org/officeDocument/2006/relationships" xmlns:a="http://schemas.openxmlformats.org/drawingml/2006/main" r:embed="Rd9d7214abe9a4afb"/>
+          <a:blip xmlns:r="http://schemas.openxmlformats.org/officeDocument/2006/relationships" xmlns:a="http://schemas.openxmlformats.org/drawingml/2006/main" r:embed="R35e09fb441d54803"/>
           <a:srcRect xmlns:a="http://schemas.openxmlformats.org/drawingml/2006/main" l="0" t="0" r="0" b="0"/>
           <a:stretch xmlns:a="http://schemas.openxmlformats.org/drawingml/2006/main">
             <a:fillRect l="0" t="0" r="0" b="0"/>
@@ -1586,7 +1586,7 @@
     </p:spTree>
     <p:extLst>
       <p:ext uri="{BB962C8B-B14F-4D97-AF65-F5344CB8AC3E}">
-        <p14:creationId xmlns:p14="http://schemas.microsoft.com/office/powerpoint/2010/main" val="1642516872"/>
+        <p14:creationId xmlns:p14="http://schemas.microsoft.com/office/powerpoint/2010/main" val="2045073733"/>
       </p:ext>
     </p:extLst>
   </p:cSld>
@@ -1614,7 +1614,7 @@
           <p:nvPr/>
         </p:nvPicPr>
         <p:blipFill>
-          <a:blip xmlns:r="http://schemas.openxmlformats.org/officeDocument/2006/relationships" xmlns:a="http://schemas.openxmlformats.org/drawingml/2006/main" r:embed="R3864fb018f0b458a"/>
+          <a:blip xmlns:r="http://schemas.openxmlformats.org/officeDocument/2006/relationships" xmlns:a="http://schemas.openxmlformats.org/drawingml/2006/main" r:embed="R278b2055b5b54928"/>
           <a:srcRect xmlns:a="http://schemas.openxmlformats.org/drawingml/2006/main" l="0" t="0" r="0" b="0"/>
           <a:stretch xmlns:a="http://schemas.openxmlformats.org/drawingml/2006/main">
             <a:fillRect l="0" t="0" r="0" b="0"/>
@@ -1633,7 +1633,7 @@
     </p:spTree>
     <p:extLst>
       <p:ext uri="{BB962C8B-B14F-4D97-AF65-F5344CB8AC3E}">
-        <p14:creationId xmlns:p14="http://schemas.microsoft.com/office/powerpoint/2010/main" val="1483576376"/>
+        <p14:creationId xmlns:p14="http://schemas.microsoft.com/office/powerpoint/2010/main" val="1516569829"/>
       </p:ext>
     </p:extLst>
   </p:cSld>
@@ -1661,7 +1661,7 @@
           <p:nvPr/>
         </p:nvPicPr>
         <p:blipFill>
-          <a:blip xmlns:r="http://schemas.openxmlformats.org/officeDocument/2006/relationships" xmlns:a="http://schemas.openxmlformats.org/drawingml/2006/main" r:embed="Rc97eb1b55ae6440b"/>
+          <a:blip xmlns:r="http://schemas.openxmlformats.org/officeDocument/2006/relationships" xmlns:a="http://schemas.openxmlformats.org/drawingml/2006/main" r:embed="Rce4b31525ee44f30"/>
           <a:srcRect xmlns:a="http://schemas.openxmlformats.org/drawingml/2006/main" l="0" t="0" r="0" b="0"/>
           <a:stretch xmlns:a="http://schemas.openxmlformats.org/drawingml/2006/main">
             <a:fillRect l="0" t="0" r="0" b="0"/>
@@ -1680,7 +1680,7 @@
     </p:spTree>
     <p:extLst>
       <p:ext uri="{BB962C8B-B14F-4D97-AF65-F5344CB8AC3E}">
-        <p14:creationId xmlns:p14="http://schemas.microsoft.com/office/powerpoint/2010/main" val="1397181396"/>
+        <p14:creationId xmlns:p14="http://schemas.microsoft.com/office/powerpoint/2010/main" val="331019872"/>
       </p:ext>
     </p:extLst>
   </p:cSld>
@@ -1708,7 +1708,7 @@
           <p:nvPr/>
         </p:nvPicPr>
         <p:blipFill>
-          <a:blip xmlns:r="http://schemas.openxmlformats.org/officeDocument/2006/relationships" xmlns:a="http://schemas.openxmlformats.org/drawingml/2006/main" r:embed="R1d7842d9b8134151"/>
+          <a:blip xmlns:r="http://schemas.openxmlformats.org/officeDocument/2006/relationships" xmlns:a="http://schemas.openxmlformats.org/drawingml/2006/main" r:embed="R0adf5713b5354a72"/>
           <a:srcRect xmlns:a="http://schemas.openxmlformats.org/drawingml/2006/main" l="0" t="0" r="0" b="0"/>
           <a:stretch xmlns:a="http://schemas.openxmlformats.org/drawingml/2006/main">
             <a:fillRect l="0" t="0" r="0" b="0"/>
@@ -1727,7 +1727,7 @@
     </p:spTree>
     <p:extLst>
       <p:ext uri="{BB962C8B-B14F-4D97-AF65-F5344CB8AC3E}">
-        <p14:creationId xmlns:p14="http://schemas.microsoft.com/office/powerpoint/2010/main" val="41589010"/>
+        <p14:creationId xmlns:p14="http://schemas.microsoft.com/office/powerpoint/2010/main" val="1693037913"/>
       </p:ext>
     </p:extLst>
   </p:cSld>

</xml_diff>

<commit_message>
Redesign profile slide as rising timeline
</commit_message>
<xml_diff>
--- a/outputs/ability-demo-v5.pptx
+++ b/outputs/ability-demo-v5.pptx
@@ -2,18 +2,18 @@
 <file path=ppt/presentation.xml><?xml version="1.0" encoding="utf-8"?>
 <p:presentation xmlns:p="http://schemas.openxmlformats.org/presentationml/2006/main">
   <p:sldMasterIdLst>
-    <p:sldMasterId xmlns:r="http://schemas.openxmlformats.org/officeDocument/2006/relationships" id="2147483648" r:id="R912b874d2e67483f"/>
+    <p:sldMasterId xmlns:r="http://schemas.openxmlformats.org/officeDocument/2006/relationships" id="2147483648" r:id="R688d91dee0024ae6"/>
   </p:sldMasterIdLst>
   <p:notesMasterIdLst>
-    <p:notesMasterId xmlns:r="http://schemas.openxmlformats.org/officeDocument/2006/relationships" r:id="R05726b2250a845cb"/>
+    <p:notesMasterId xmlns:r="http://schemas.openxmlformats.org/officeDocument/2006/relationships" r:id="Re397b55459184f96"/>
   </p:notesMasterIdLst>
   <p:sldIdLst>
-    <p:sldId xmlns:r="http://schemas.openxmlformats.org/officeDocument/2006/relationships" id="256" r:id="R0db13da6b8494067"/>
-    <p:sldId xmlns:r="http://schemas.openxmlformats.org/officeDocument/2006/relationships" id="257" r:id="Rc0089013b30c45ff"/>
-    <p:sldId xmlns:r="http://schemas.openxmlformats.org/officeDocument/2006/relationships" id="258" r:id="Rf7cff6414d5c47cb"/>
-    <p:sldId xmlns:r="http://schemas.openxmlformats.org/officeDocument/2006/relationships" id="259" r:id="Rfee9c4db10b049b1"/>
-    <p:sldId xmlns:r="http://schemas.openxmlformats.org/officeDocument/2006/relationships" id="260" r:id="Re7c962c260044e18"/>
-    <p:sldId xmlns:r="http://schemas.openxmlformats.org/officeDocument/2006/relationships" id="261" r:id="Re639a0a2488e4693"/>
+    <p:sldId xmlns:r="http://schemas.openxmlformats.org/officeDocument/2006/relationships" id="256" r:id="Raa359ce1d5724646"/>
+    <p:sldId xmlns:r="http://schemas.openxmlformats.org/officeDocument/2006/relationships" id="257" r:id="Rb588d84991854584"/>
+    <p:sldId xmlns:r="http://schemas.openxmlformats.org/officeDocument/2006/relationships" id="258" r:id="Rad6cf04b4ad24f71"/>
+    <p:sldId xmlns:r="http://schemas.openxmlformats.org/officeDocument/2006/relationships" id="259" r:id="Rebd3691f2f9949a7"/>
+    <p:sldId xmlns:r="http://schemas.openxmlformats.org/officeDocument/2006/relationships" id="260" r:id="R06c7876a513949fd"/>
+    <p:sldId xmlns:r="http://schemas.openxmlformats.org/officeDocument/2006/relationships" id="261" r:id="R880f02a267cd4ed8"/>
   </p:sldIdLst>
   <p:sldSz cx="12192000" cy="6858000"/>
   <p:notesSz cx="6858000" cy="9144000"/>
@@ -925,7 +925,7 @@
   </p:cSld>
   <p:clrMap bg1="lt1" tx1="dk1" bg2="lt2" tx2="dk2" accent1="accent1" accent2="accent2" accent3="accent3" accent4="accent4" accent5="accent5" accent6="accent6" hlink="hlink" folHlink="folHlink"/>
   <p:sldLayoutIdLst>
-    <p:sldLayoutId xmlns:r="http://schemas.openxmlformats.org/officeDocument/2006/relationships" id="2147483649" r:id="R1de4d8fbee5e4d72"/>
+    <p:sldLayoutId xmlns:r="http://schemas.openxmlformats.org/officeDocument/2006/relationships" id="2147483649" r:id="Ra58b371490a64f7c"/>
   </p:sldLayoutIdLst>
   <p:txStyles>
     <p:titleStyle>
@@ -1473,7 +1473,7 @@
           <p:nvPr/>
         </p:nvPicPr>
         <p:blipFill>
-          <a:blip xmlns:r="http://schemas.openxmlformats.org/officeDocument/2006/relationships" xmlns:a="http://schemas.openxmlformats.org/drawingml/2006/main" r:embed="R615118be5fe14f8a"/>
+          <a:blip xmlns:r="http://schemas.openxmlformats.org/officeDocument/2006/relationships" xmlns:a="http://schemas.openxmlformats.org/drawingml/2006/main" r:embed="R9c05e26ff7f3469f"/>
           <a:srcRect xmlns:a="http://schemas.openxmlformats.org/drawingml/2006/main" l="0" t="0" r="0" b="0"/>
           <a:stretch xmlns:a="http://schemas.openxmlformats.org/drawingml/2006/main">
             <a:fillRect l="0" t="0" r="0" b="0"/>
@@ -1492,7 +1492,7 @@
     </p:spTree>
     <p:extLst>
       <p:ext uri="{BB962C8B-B14F-4D97-AF65-F5344CB8AC3E}">
-        <p14:creationId xmlns:p14="http://schemas.microsoft.com/office/powerpoint/2010/main" val="170170889"/>
+        <p14:creationId xmlns:p14="http://schemas.microsoft.com/office/powerpoint/2010/main" val="1564236779"/>
       </p:ext>
     </p:extLst>
   </p:cSld>
@@ -1520,7 +1520,7 @@
           <p:nvPr/>
         </p:nvPicPr>
         <p:blipFill>
-          <a:blip xmlns:r="http://schemas.openxmlformats.org/officeDocument/2006/relationships" xmlns:a="http://schemas.openxmlformats.org/drawingml/2006/main" r:embed="R03312485a2824ece"/>
+          <a:blip xmlns:r="http://schemas.openxmlformats.org/officeDocument/2006/relationships" xmlns:a="http://schemas.openxmlformats.org/drawingml/2006/main" r:embed="Ra05a756d96d44f42"/>
           <a:srcRect xmlns:a="http://schemas.openxmlformats.org/drawingml/2006/main" l="0" t="0" r="0" b="0"/>
           <a:stretch xmlns:a="http://schemas.openxmlformats.org/drawingml/2006/main">
             <a:fillRect l="0" t="0" r="0" b="0"/>
@@ -1539,7 +1539,7 @@
     </p:spTree>
     <p:extLst>
       <p:ext uri="{BB962C8B-B14F-4D97-AF65-F5344CB8AC3E}">
-        <p14:creationId xmlns:p14="http://schemas.microsoft.com/office/powerpoint/2010/main" val="1353455036"/>
+        <p14:creationId xmlns:p14="http://schemas.microsoft.com/office/powerpoint/2010/main" val="2014816821"/>
       </p:ext>
     </p:extLst>
   </p:cSld>
@@ -1567,7 +1567,7 @@
           <p:nvPr/>
         </p:nvPicPr>
         <p:blipFill>
-          <a:blip xmlns:r="http://schemas.openxmlformats.org/officeDocument/2006/relationships" xmlns:a="http://schemas.openxmlformats.org/drawingml/2006/main" r:embed="R35e09fb441d54803"/>
+          <a:blip xmlns:r="http://schemas.openxmlformats.org/officeDocument/2006/relationships" xmlns:a="http://schemas.openxmlformats.org/drawingml/2006/main" r:embed="R3f1d9c6272a246e3"/>
           <a:srcRect xmlns:a="http://schemas.openxmlformats.org/drawingml/2006/main" l="0" t="0" r="0" b="0"/>
           <a:stretch xmlns:a="http://schemas.openxmlformats.org/drawingml/2006/main">
             <a:fillRect l="0" t="0" r="0" b="0"/>
@@ -1586,7 +1586,7 @@
     </p:spTree>
     <p:extLst>
       <p:ext uri="{BB962C8B-B14F-4D97-AF65-F5344CB8AC3E}">
-        <p14:creationId xmlns:p14="http://schemas.microsoft.com/office/powerpoint/2010/main" val="2045073733"/>
+        <p14:creationId xmlns:p14="http://schemas.microsoft.com/office/powerpoint/2010/main" val="379657574"/>
       </p:ext>
     </p:extLst>
   </p:cSld>
@@ -1614,7 +1614,7 @@
           <p:nvPr/>
         </p:nvPicPr>
         <p:blipFill>
-          <a:blip xmlns:r="http://schemas.openxmlformats.org/officeDocument/2006/relationships" xmlns:a="http://schemas.openxmlformats.org/drawingml/2006/main" r:embed="R278b2055b5b54928"/>
+          <a:blip xmlns:r="http://schemas.openxmlformats.org/officeDocument/2006/relationships" xmlns:a="http://schemas.openxmlformats.org/drawingml/2006/main" r:embed="R9b45c779fdb74225"/>
           <a:srcRect xmlns:a="http://schemas.openxmlformats.org/drawingml/2006/main" l="0" t="0" r="0" b="0"/>
           <a:stretch xmlns:a="http://schemas.openxmlformats.org/drawingml/2006/main">
             <a:fillRect l="0" t="0" r="0" b="0"/>
@@ -1633,7 +1633,7 @@
     </p:spTree>
     <p:extLst>
       <p:ext uri="{BB962C8B-B14F-4D97-AF65-F5344CB8AC3E}">
-        <p14:creationId xmlns:p14="http://schemas.microsoft.com/office/powerpoint/2010/main" val="1516569829"/>
+        <p14:creationId xmlns:p14="http://schemas.microsoft.com/office/powerpoint/2010/main" val="194661834"/>
       </p:ext>
     </p:extLst>
   </p:cSld>
@@ -1661,7 +1661,7 @@
           <p:nvPr/>
         </p:nvPicPr>
         <p:blipFill>
-          <a:blip xmlns:r="http://schemas.openxmlformats.org/officeDocument/2006/relationships" xmlns:a="http://schemas.openxmlformats.org/drawingml/2006/main" r:embed="Rce4b31525ee44f30"/>
+          <a:blip xmlns:r="http://schemas.openxmlformats.org/officeDocument/2006/relationships" xmlns:a="http://schemas.openxmlformats.org/drawingml/2006/main" r:embed="Rc826bf283815407b"/>
           <a:srcRect xmlns:a="http://schemas.openxmlformats.org/drawingml/2006/main" l="0" t="0" r="0" b="0"/>
           <a:stretch xmlns:a="http://schemas.openxmlformats.org/drawingml/2006/main">
             <a:fillRect l="0" t="0" r="0" b="0"/>
@@ -1680,7 +1680,7 @@
     </p:spTree>
     <p:extLst>
       <p:ext uri="{BB962C8B-B14F-4D97-AF65-F5344CB8AC3E}">
-        <p14:creationId xmlns:p14="http://schemas.microsoft.com/office/powerpoint/2010/main" val="331019872"/>
+        <p14:creationId xmlns:p14="http://schemas.microsoft.com/office/powerpoint/2010/main" val="1651190013"/>
       </p:ext>
     </p:extLst>
   </p:cSld>
@@ -1708,7 +1708,7 @@
           <p:nvPr/>
         </p:nvPicPr>
         <p:blipFill>
-          <a:blip xmlns:r="http://schemas.openxmlformats.org/officeDocument/2006/relationships" xmlns:a="http://schemas.openxmlformats.org/drawingml/2006/main" r:embed="R0adf5713b5354a72"/>
+          <a:blip xmlns:r="http://schemas.openxmlformats.org/officeDocument/2006/relationships" xmlns:a="http://schemas.openxmlformats.org/drawingml/2006/main" r:embed="R49fe74e0dba445ee"/>
           <a:srcRect xmlns:a="http://schemas.openxmlformats.org/drawingml/2006/main" l="0" t="0" r="0" b="0"/>
           <a:stretch xmlns:a="http://schemas.openxmlformats.org/drawingml/2006/main">
             <a:fillRect l="0" t="0" r="0" b="0"/>
@@ -1727,7 +1727,7 @@
     </p:spTree>
     <p:extLst>
       <p:ext uri="{BB962C8B-B14F-4D97-AF65-F5344CB8AC3E}">
-        <p14:creationId xmlns:p14="http://schemas.microsoft.com/office/powerpoint/2010/main" val="1693037913"/>
+        <p14:creationId xmlns:p14="http://schemas.microsoft.com/office/powerpoint/2010/main" val="301882095"/>
       </p:ext>
     </p:extLst>
   </p:cSld>

</xml_diff>